<commit_message>
Update MAF documents with MAF-Quantum Extension content
Co-authored-by: wouble-u <242092992+wouble-u@users.noreply.github.com>
</commit_message>
<xml_diff>
--- a/docs/MAF_Presentation.pptx
+++ b/docs/MAF_Presentation.pptx
@@ -14,6 +14,13 @@
     <p:sldId id="262" r:id="rId13"/>
     <p:sldId id="263" r:id="rId14"/>
     <p:sldId id="264" r:id="rId15"/>
+    <p:sldId id="265" r:id="rId16"/>
+    <p:sldId id="266" r:id="rId17"/>
+    <p:sldId id="267" r:id="rId18"/>
+    <p:sldId id="268" r:id="rId19"/>
+    <p:sldId id="269" r:id="rId20"/>
+    <p:sldId id="270" r:id="rId21"/>
+    <p:sldId id="271" r:id="rId22"/>
   </p:sldIdLst>
   <p:sldSz cx="9144000" cy="6858000" type="screen4x3"/>
   <p:notesSz cx="6858000" cy="9144000"/>
@@ -3134,6 +3141,593 @@
           <a:p>
             <a:r>
               <a:t>Unified Presentation • Dogan Aramaci &amp; ChatGPT</a:t>
+            </a:r>
+          </a:p>
+        </p:txBody>
+      </p:sp>
+    </p:spTree>
+  </p:cSld>
+  <p:clrMapOvr>
+    <a:masterClrMapping/>
+  </p:clrMapOvr>
+</p:sld>
+</file>
+
+<file path=ppt/slides/slide10.xml><?xml version="1.0" encoding="utf-8"?>
+<p:sld xmlns:a="http://schemas.openxmlformats.org/drawingml/2006/main" xmlns:p="http://schemas.openxmlformats.org/presentationml/2006/main" xmlns:r="http://schemas.openxmlformats.org/officeDocument/2006/relationships">
+  <p:cSld>
+    <p:spTree>
+      <p:nvGrpSpPr>
+        <p:cNvPr id="1" name=""/>
+        <p:cNvGrpSpPr/>
+        <p:nvPr/>
+      </p:nvGrpSpPr>
+      <p:grpSpPr/>
+      <p:sp>
+        <p:nvSpPr>
+          <p:cNvPr id="2" name="Title 1"/>
+          <p:cNvSpPr>
+            <a:spLocks noGrp="1"/>
+          </p:cNvSpPr>
+          <p:nvPr>
+            <p:ph type="title"/>
+          </p:nvPr>
+        </p:nvSpPr>
+        <p:spPr/>
+        <p:txBody>
+          <a:bodyPr/>
+          <a:lstStyle/>
+          <a:p>
+            <a:r>
+              <a:t>MAF-Quantum Extension</a:t>
+            </a:r>
+          </a:p>
+        </p:txBody>
+      </p:sp>
+      <p:sp>
+        <p:nvSpPr>
+          <p:cNvPr id="3" name="Content Placeholder 2"/>
+          <p:cNvSpPr>
+            <a:spLocks noGrp="1"/>
+          </p:cNvSpPr>
+          <p:nvPr>
+            <p:ph idx="1"/>
+          </p:nvPr>
+        </p:nvSpPr>
+        <p:spPr/>
+        <p:txBody>
+          <a:bodyPr/>
+          <a:lstStyle/>
+          <a:p>
+            <a:r>
+              <a:t>This section extends MAF with quantum mechanical formulations.</a:t>
+            </a:r>
+          </a:p>
+          <a:p/>
+          <a:p>
+            <a:r>
+              <a:t>The quantum layer adds three new principles:</a:t>
+            </a:r>
+          </a:p>
+          <a:p>
+            <a:r>
+              <a:t>  Principle 5: Quantum Spin as the Foundation of Atomic Magnetism</a:t>
+            </a:r>
+          </a:p>
+          <a:p>
+            <a:r>
+              <a:t>  Principle 6: Quantum Coherence in Biological Magnetic Networks</a:t>
+            </a:r>
+          </a:p>
+          <a:p>
+            <a:r>
+              <a:t>  Principle 7: Quantum Entanglement in Fractal Magnetic Symmetry</a:t>
+            </a:r>
+          </a:p>
+        </p:txBody>
+      </p:sp>
+    </p:spTree>
+  </p:cSld>
+  <p:clrMapOvr>
+    <a:masterClrMapping/>
+  </p:clrMapOvr>
+</p:sld>
+</file>
+
+<file path=ppt/slides/slide11.xml><?xml version="1.0" encoding="utf-8"?>
+<p:sld xmlns:a="http://schemas.openxmlformats.org/drawingml/2006/main" xmlns:p="http://schemas.openxmlformats.org/presentationml/2006/main" xmlns:r="http://schemas.openxmlformats.org/officeDocument/2006/relationships">
+  <p:cSld>
+    <p:spTree>
+      <p:nvGrpSpPr>
+        <p:cNvPr id="1" name=""/>
+        <p:cNvGrpSpPr/>
+        <p:nvPr/>
+      </p:nvGrpSpPr>
+      <p:grpSpPr/>
+      <p:sp>
+        <p:nvSpPr>
+          <p:cNvPr id="2" name="Title 1"/>
+          <p:cNvSpPr>
+            <a:spLocks noGrp="1"/>
+          </p:cNvSpPr>
+          <p:nvPr>
+            <p:ph type="title"/>
+          </p:nvPr>
+        </p:nvSpPr>
+        <p:spPr/>
+        <p:txBody>
+          <a:bodyPr/>
+          <a:lstStyle/>
+          <a:p>
+            <a:r>
+              <a:t>Principle 5: Quantum Spin &amp; Atomic Magnetism</a:t>
+            </a:r>
+          </a:p>
+        </p:txBody>
+      </p:sp>
+      <p:sp>
+        <p:nvSpPr>
+          <p:cNvPr id="3" name="Content Placeholder 2"/>
+          <p:cNvSpPr>
+            <a:spLocks noGrp="1"/>
+          </p:cNvSpPr>
+          <p:nvPr>
+            <p:ph idx="1"/>
+          </p:nvPr>
+        </p:nvSpPr>
+        <p:spPr/>
+        <p:txBody>
+          <a:bodyPr/>
+          <a:lstStyle/>
+          <a:p>
+            <a:r>
+              <a:t>MAF-Quantum posits that atomic magnetic identity originates from quantum spin states.</a:t>
+            </a:r>
+          </a:p>
+          <a:p/>
+          <a:p>
+            <a:r>
+              <a:t>Every electron and nucleus carries intrinsic angular momentum (spin) described by quantum numbers. The net magnetic moment is the vectorial sum of all spin and orbital contributions.</a:t>
+            </a:r>
+          </a:p>
+          <a:p/>
+          <a:p>
+            <a:r>
+              <a:t>Key Formula:</a:t>
+            </a:r>
+          </a:p>
+          <a:p>
+            <a:r>
+              <a:t>µa = g · µB · sqrt(s(s+1))</a:t>
+            </a:r>
+          </a:p>
+          <a:p/>
+          <a:p>
+            <a:r>
+              <a:t>Where g is the Landé g-factor, µB is the Bohr magneton, and s is the spin quantum number.</a:t>
+            </a:r>
+          </a:p>
+        </p:txBody>
+      </p:sp>
+    </p:spTree>
+  </p:cSld>
+  <p:clrMapOvr>
+    <a:masterClrMapping/>
+  </p:clrMapOvr>
+</p:sld>
+</file>
+
+<file path=ppt/slides/slide12.xml><?xml version="1.0" encoding="utf-8"?>
+<p:sld xmlns:a="http://schemas.openxmlformats.org/drawingml/2006/main" xmlns:p="http://schemas.openxmlformats.org/presentationml/2006/main" xmlns:r="http://schemas.openxmlformats.org/officeDocument/2006/relationships">
+  <p:cSld>
+    <p:spTree>
+      <p:nvGrpSpPr>
+        <p:cNvPr id="1" name=""/>
+        <p:cNvGrpSpPr/>
+        <p:nvPr/>
+      </p:nvGrpSpPr>
+      <p:grpSpPr/>
+      <p:sp>
+        <p:nvSpPr>
+          <p:cNvPr id="2" name="Title 1"/>
+          <p:cNvSpPr>
+            <a:spLocks noGrp="1"/>
+          </p:cNvSpPr>
+          <p:nvPr>
+            <p:ph type="title"/>
+          </p:nvPr>
+        </p:nvSpPr>
+        <p:spPr/>
+        <p:txBody>
+          <a:bodyPr/>
+          <a:lstStyle/>
+          <a:p>
+            <a:r>
+              <a:t>Principle 6: Quantum Coherence in Biology</a:t>
+            </a:r>
+          </a:p>
+        </p:txBody>
+      </p:sp>
+      <p:sp>
+        <p:nvSpPr>
+          <p:cNvPr id="3" name="Content Placeholder 2"/>
+          <p:cNvSpPr>
+            <a:spLocks noGrp="1"/>
+          </p:cNvSpPr>
+          <p:nvPr>
+            <p:ph idx="1"/>
+          </p:nvPr>
+        </p:nvSpPr>
+        <p:spPr/>
+        <p:txBody>
+          <a:bodyPr/>
+          <a:lstStyle/>
+          <a:p>
+            <a:r>
+              <a:t>MAF-Quantum proposes that the human magnetic lattice (MH) involves quantum coherence effects — transient quantum correlations between atoms within biological macromolecules (proteins, DNA).</a:t>
+            </a:r>
+          </a:p>
+          <a:p/>
+          <a:p>
+            <a:r>
+              <a:t>Key Formula:</a:t>
+            </a:r>
+          </a:p>
+          <a:p>
+            <a:r>
+              <a:t>MH(quantum) = MH(classical) + Delta_coherence</a:t>
+            </a:r>
+          </a:p>
+          <a:p/>
+          <a:p>
+            <a:r>
+              <a:t>Delta_coherence represents the coherence-enhanced contribution from entangled spin states in ordered biological structures.</a:t>
+            </a:r>
+          </a:p>
+          <a:p/>
+          <a:p>
+            <a:r>
+              <a:t>Quantum coherence amplifies the effective magnetic signal beyond classical summation.</a:t>
+            </a:r>
+          </a:p>
+        </p:txBody>
+      </p:sp>
+    </p:spTree>
+  </p:cSld>
+  <p:clrMapOvr>
+    <a:masterClrMapping/>
+  </p:clrMapOvr>
+</p:sld>
+</file>
+
+<file path=ppt/slides/slide13.xml><?xml version="1.0" encoding="utf-8"?>
+<p:sld xmlns:a="http://schemas.openxmlformats.org/drawingml/2006/main" xmlns:p="http://schemas.openxmlformats.org/presentationml/2006/main" xmlns:r="http://schemas.openxmlformats.org/officeDocument/2006/relationships">
+  <p:cSld>
+    <p:spTree>
+      <p:nvGrpSpPr>
+        <p:cNvPr id="1" name=""/>
+        <p:cNvGrpSpPr/>
+        <p:nvPr/>
+      </p:nvGrpSpPr>
+      <p:grpSpPr/>
+      <p:sp>
+        <p:nvSpPr>
+          <p:cNvPr id="2" name="Title 1"/>
+          <p:cNvSpPr>
+            <a:spLocks noGrp="1"/>
+          </p:cNvSpPr>
+          <p:nvPr>
+            <p:ph type="title"/>
+          </p:nvPr>
+        </p:nvSpPr>
+        <p:spPr/>
+        <p:txBody>
+          <a:bodyPr/>
+          <a:lstStyle/>
+          <a:p>
+            <a:r>
+              <a:t>Principle 7: Quantum Entanglement &amp; Fractal Symmetry</a:t>
+            </a:r>
+          </a:p>
+        </p:txBody>
+      </p:sp>
+      <p:sp>
+        <p:nvSpPr>
+          <p:cNvPr id="3" name="Content Placeholder 2"/>
+          <p:cNvSpPr>
+            <a:spLocks noGrp="1"/>
+          </p:cNvSpPr>
+          <p:nvPr>
+            <p:ph idx="1"/>
+          </p:nvPr>
+        </p:nvSpPr>
+        <p:spPr/>
+        <p:txBody>
+          <a:bodyPr/>
+          <a:lstStyle/>
+          <a:p>
+            <a:r>
+              <a:t>MAF-Quantum extends fractal correspondence (Principle 4) by proposing that quantum entanglement links magnetic states across scales.</a:t>
+            </a:r>
+          </a:p>
+          <a:p/>
+          <a:p>
+            <a:r>
+              <a:t>Key Formula:</a:t>
+            </a:r>
+          </a:p>
+          <a:p>
+            <a:r>
+              <a:t>|psi_system&gt; = Σ ai |µai&gt; ⊗ |MHi&gt; ⊗ |MGi&gt;</a:t>
+            </a:r>
+          </a:p>
+          <a:p/>
+          <a:p>
+            <a:r>
+              <a:t>This represents the system as a quantum superposition of correlated atomic, biological, and planetary magnetic states.</a:t>
+            </a:r>
+          </a:p>
+          <a:p/>
+          <a:p>
+            <a:r>
+              <a:t>Local atomic spin states may be non-locally correlated with macroscopic field structures.</a:t>
+            </a:r>
+          </a:p>
+        </p:txBody>
+      </p:sp>
+    </p:spTree>
+  </p:cSld>
+  <p:clrMapOvr>
+    <a:masterClrMapping/>
+  </p:clrMapOvr>
+</p:sld>
+</file>
+
+<file path=ppt/slides/slide14.xml><?xml version="1.0" encoding="utf-8"?>
+<p:sld xmlns:a="http://schemas.openxmlformats.org/drawingml/2006/main" xmlns:p="http://schemas.openxmlformats.org/presentationml/2006/main" xmlns:r="http://schemas.openxmlformats.org/officeDocument/2006/relationships">
+  <p:cSld>
+    <p:spTree>
+      <p:nvGrpSpPr>
+        <p:cNvPr id="1" name=""/>
+        <p:cNvGrpSpPr/>
+        <p:nvPr/>
+      </p:nvGrpSpPr>
+      <p:grpSpPr/>
+      <p:sp>
+        <p:nvSpPr>
+          <p:cNvPr id="2" name="Title 1"/>
+          <p:cNvSpPr>
+            <a:spLocks noGrp="1"/>
+          </p:cNvSpPr>
+          <p:nvPr>
+            <p:ph type="title"/>
+          </p:nvPr>
+        </p:nvSpPr>
+        <p:spPr/>
+        <p:txBody>
+          <a:bodyPr/>
+          <a:lstStyle/>
+          <a:p>
+            <a:r>
+              <a:t>Quantum Mathematical Formulations</a:t>
+            </a:r>
+          </a:p>
+        </p:txBody>
+      </p:sp>
+      <p:sp>
+        <p:nvSpPr>
+          <p:cNvPr id="3" name="Content Placeholder 2"/>
+          <p:cNvSpPr>
+            <a:spLocks noGrp="1"/>
+          </p:cNvSpPr>
+          <p:nvPr>
+            <p:ph idx="1"/>
+          </p:nvPr>
+        </p:nvSpPr>
+        <p:spPr/>
+        <p:txBody>
+          <a:bodyPr/>
+          <a:lstStyle/>
+          <a:p>
+            <a:r>
+              <a:t>Q.1 Quantum Atomic Magnetic Moment:</a:t>
+            </a:r>
+          </a:p>
+          <a:p>
+            <a:r>
+              <a:t>µa = -gJ · µB · J</a:t>
+            </a:r>
+          </a:p>
+          <a:p>
+            <a:r>
+              <a:t>gJ = 1 + [J(J+1) + S(S+1) - L(L+1)] / [2J(J+1)]</a:t>
+            </a:r>
+          </a:p>
+          <a:p/>
+          <a:p>
+            <a:r>
+              <a:t>Q.2 Quantum Hamiltonian (energy in external field B):</a:t>
+            </a:r>
+          </a:p>
+          <a:p>
+            <a:r>
+              <a:t>H = -µa · B = gJ · µB · mJ · B</a:t>
+            </a:r>
+          </a:p>
+          <a:p/>
+          <a:p>
+            <a:r>
+              <a:t>Q.3 Coherence-Enhanced Human Magnetic Structure:</a:t>
+            </a:r>
+          </a:p>
+          <a:p>
+            <a:r>
+              <a:t>MH = Σi &lt;psi_i|µai|psi_i&gt; × (biological order)i × C_quantum</a:t>
+            </a:r>
+          </a:p>
+        </p:txBody>
+      </p:sp>
+    </p:spTree>
+  </p:cSld>
+  <p:clrMapOvr>
+    <a:masterClrMapping/>
+  </p:clrMapOvr>
+</p:sld>
+</file>
+
+<file path=ppt/slides/slide15.xml><?xml version="1.0" encoding="utf-8"?>
+<p:sld xmlns:a="http://schemas.openxmlformats.org/drawingml/2006/main" xmlns:p="http://schemas.openxmlformats.org/presentationml/2006/main" xmlns:r="http://schemas.openxmlformats.org/officeDocument/2006/relationships">
+  <p:cSld>
+    <p:spTree>
+      <p:nvGrpSpPr>
+        <p:cNvPr id="1" name=""/>
+        <p:cNvGrpSpPr/>
+        <p:nvPr/>
+      </p:nvGrpSpPr>
+      <p:grpSpPr/>
+      <p:sp>
+        <p:nvSpPr>
+          <p:cNvPr id="2" name="Title 1"/>
+          <p:cNvSpPr>
+            <a:spLocks noGrp="1"/>
+          </p:cNvSpPr>
+          <p:nvPr>
+            <p:ph type="title"/>
+          </p:nvPr>
+        </p:nvSpPr>
+        <p:spPr/>
+        <p:txBody>
+          <a:bodyPr/>
+          <a:lstStyle/>
+          <a:p>
+            <a:r>
+              <a:t>Quantum Implications</a:t>
+            </a:r>
+          </a:p>
+        </p:txBody>
+      </p:sp>
+      <p:sp>
+        <p:nvSpPr>
+          <p:cNvPr id="3" name="Content Placeholder 2"/>
+          <p:cNvSpPr>
+            <a:spLocks noGrp="1"/>
+          </p:cNvSpPr>
+          <p:nvPr>
+            <p:ph idx="1"/>
+          </p:nvPr>
+        </p:nvSpPr>
+        <p:spPr/>
+        <p:txBody>
+          <a:bodyPr/>
+          <a:lstStyle/>
+          <a:p>
+            <a:r>
+              <a:t>• Quantum Biology: Biological sensitivity to magnetic fields may be mediated by quantum coherence effects in radical-pair mechanisms (related to avian magnetoreception models).</a:t>
+            </a:r>
+          </a:p>
+          <a:p/>
+          <a:p>
+            <a:r>
+              <a:t>• Macroscopic Quantum Effects: Planetary magnetic cycles may influence quantum decoherence rates in biological systems — a theoretical quantum bridge between cosmic and cellular scales.</a:t>
+            </a:r>
+          </a:p>
+          <a:p/>
+          <a:p>
+            <a:r>
+              <a:t>• Quantum &amp; Consciousness: Collapse of quantum spin superpositions in neural magnetic structures may contribute to conscious experience (highly theoretical).</a:t>
+            </a:r>
+          </a:p>
+          <a:p/>
+          <a:p>
+            <a:r>
+              <a:t>• Entangled Field Dynamics: Perturbations in atomic spin ensembles may propagate coherently across biological and planetary scales.</a:t>
+            </a:r>
+          </a:p>
+        </p:txBody>
+      </p:sp>
+    </p:spTree>
+  </p:cSld>
+  <p:clrMapOvr>
+    <a:masterClrMapping/>
+  </p:clrMapOvr>
+</p:sld>
+</file>
+
+<file path=ppt/slides/slide16.xml><?xml version="1.0" encoding="utf-8"?>
+<p:sld xmlns:a="http://schemas.openxmlformats.org/drawingml/2006/main" xmlns:p="http://schemas.openxmlformats.org/presentationml/2006/main" xmlns:r="http://schemas.openxmlformats.org/officeDocument/2006/relationships">
+  <p:cSld>
+    <p:spTree>
+      <p:nvGrpSpPr>
+        <p:cNvPr id="1" name=""/>
+        <p:cNvGrpSpPr/>
+        <p:nvPr/>
+      </p:nvGrpSpPr>
+      <p:grpSpPr/>
+      <p:sp>
+        <p:nvSpPr>
+          <p:cNvPr id="2" name="Title 1"/>
+          <p:cNvSpPr>
+            <a:spLocks noGrp="1"/>
+          </p:cNvSpPr>
+          <p:nvPr>
+            <p:ph type="title"/>
+          </p:nvPr>
+        </p:nvSpPr>
+        <p:spPr/>
+        <p:txBody>
+          <a:bodyPr/>
+          <a:lstStyle/>
+          <a:p>
+            <a:r>
+              <a:t>Updated Conclusion</a:t>
+            </a:r>
+          </a:p>
+        </p:txBody>
+      </p:sp>
+      <p:sp>
+        <p:nvSpPr>
+          <p:cNvPr id="3" name="Content Placeholder 2"/>
+          <p:cNvSpPr>
+            <a:spLocks noGrp="1"/>
+          </p:cNvSpPr>
+          <p:nvPr>
+            <p:ph idx="1"/>
+          </p:nvPr>
+        </p:nvSpPr>
+        <p:spPr/>
+        <p:txBody>
+          <a:bodyPr/>
+          <a:lstStyle/>
+          <a:p>
+            <a:r>
+              <a:t>MAF-Quantum extends the original magneto-fractal framework with quantum mechanical principles, creating a unified multi-scale theory.</a:t>
+            </a:r>
+          </a:p>
+          <a:p/>
+          <a:p>
+            <a:r>
+              <a:t>The theory now spans three integrated layers:</a:t>
+            </a:r>
+          </a:p>
+          <a:p>
+            <a:r>
+              <a:t>  Classical MAF: Atomic → Biological → Planetary magnetic scaling</a:t>
+            </a:r>
+          </a:p>
+          <a:p>
+            <a:r>
+              <a:t>  MAF-Quantum: Quantum spin, coherence, and entanglement effects</a:t>
+            </a:r>
+          </a:p>
+          <a:p>
+            <a:r>
+              <a:t>  Fractal-Quantum Bridge: Non-local correlations across scales</a:t>
+            </a:r>
+          </a:p>
+          <a:p/>
+          <a:p>
+            <a:r>
+              <a:t>This remains a speculative but structured framework for future interdisciplinary scientific exploration.</a:t>
             </a:r>
           </a:p>
         </p:txBody>

</xml_diff>